<commit_message>
Insert original overview slide at position 2 — deck now 22 slides; update all outputs
</commit_message>
<xml_diff>
--- a/presentation/cloud_paradigm_presentation_v3.pptx
+++ b/presentation/cloud_paradigm_presentation_v3.pptx
@@ -9,6 +9,7 @@
   </p:notesMasterIdLst>
   <p:sldIdLst>
     <p:sldId id="256" r:id="rId2"/>
+    <p:sldId id="277" r:id="rId30"/>
     <p:sldId id="257" r:id="rId3"/>
     <p:sldId id="259" r:id="rId12"/>
     <p:sldId id="260" r:id="rId13"/>
@@ -10593,6 +10594,787 @@
 </p:sld>
 </file>
 
+<file path=ppt/slides/slide22.xml><?xml version="1.0" encoding="utf-8"?>
+<p:sld xmlns:a="http://schemas.openxmlformats.org/drawingml/2006/main" xmlns:r="http://schemas.openxmlformats.org/officeDocument/2006/relationships" xmlns:p="http://schemas.openxmlformats.org/presentationml/2006/main">
+  <p:cSld name="Slide 2">
+    <p:bg>
+      <p:bgPr>
+        <a:solidFill>
+          <a:srgbClr val="FFFFFF"/>
+        </a:solidFill>
+        <a:effectLst/>
+      </p:bgPr>
+    </p:bg>
+    <p:spTree>
+      <p:nvGrpSpPr>
+        <p:cNvPr id="1" name=""/>
+        <p:cNvGrpSpPr/>
+        <p:nvPr/>
+      </p:nvGrpSpPr>
+      <p:grpSpPr>
+        <a:xfrm>
+          <a:off x="0" y="0"/>
+          <a:ext cx="0" cy="0"/>
+          <a:chOff x="0" y="0"/>
+          <a:chExt cx="0" cy="0"/>
+        </a:xfrm>
+      </p:grpSpPr>
+      <p:sp>
+        <p:nvSpPr>
+          <p:cNvPr id="2" name="Shape 0"/>
+          <p:cNvSpPr/>
+          <p:nvPr/>
+        </p:nvSpPr>
+        <p:spPr>
+          <a:xfrm>
+            <a:off x="0" y="0"/>
+            <a:ext cx="9144000" cy="164592"/>
+          </a:xfrm>
+          <a:prstGeom prst="rect">
+            <a:avLst/>
+          </a:prstGeom>
+          <a:solidFill>
+            <a:srgbClr val="1C8F94"/>
+          </a:solidFill>
+          <a:ln w="12700">
+            <a:solidFill>
+              <a:srgbClr val="1C8F94"/>
+            </a:solidFill>
+            <a:prstDash val="solid"/>
+          </a:ln>
+        </p:spPr>
+        <p:txBody>
+          <a:bodyPr/>
+          <a:lstStyle/>
+          <a:p>
+            <a:endParaRPr lang="en-AU"/>
+          </a:p>
+        </p:txBody>
+      </p:sp>
+      <p:sp>
+        <p:nvSpPr>
+          <p:cNvPr id="3" name="Shape 1"/>
+          <p:cNvSpPr/>
+          <p:nvPr/>
+        </p:nvSpPr>
+        <p:spPr>
+          <a:xfrm>
+            <a:off x="0" y="4983480"/>
+            <a:ext cx="9144000" cy="164592"/>
+          </a:xfrm>
+          <a:prstGeom prst="rect">
+            <a:avLst/>
+          </a:prstGeom>
+          <a:solidFill>
+            <a:srgbClr val="008BFE"/>
+          </a:solidFill>
+          <a:ln w="12700">
+            <a:solidFill>
+              <a:srgbClr val="008BFE"/>
+            </a:solidFill>
+            <a:prstDash val="solid"/>
+          </a:ln>
+        </p:spPr>
+        <p:txBody>
+          <a:bodyPr/>
+          <a:lstStyle/>
+          <a:p>
+            <a:endParaRPr lang="en-AU"/>
+          </a:p>
+        </p:txBody>
+      </p:sp>
+      <p:sp>
+        <p:nvSpPr>
+          <p:cNvPr id="4" name="Shape 2"/>
+          <p:cNvSpPr/>
+          <p:nvPr/>
+        </p:nvSpPr>
+        <p:spPr>
+          <a:xfrm>
+            <a:off x="0" y="164592"/>
+            <a:ext cx="128016" cy="4809744"/>
+          </a:xfrm>
+          <a:prstGeom prst="rect">
+            <a:avLst/>
+          </a:prstGeom>
+          <a:solidFill>
+            <a:srgbClr val="259D77"/>
+          </a:solidFill>
+          <a:ln w="12700">
+            <a:solidFill>
+              <a:srgbClr val="259D77"/>
+            </a:solidFill>
+            <a:prstDash val="solid"/>
+          </a:ln>
+        </p:spPr>
+        <p:txBody>
+          <a:bodyPr/>
+          <a:lstStyle/>
+          <a:p>
+            <a:endParaRPr lang="en-AU"/>
+          </a:p>
+        </p:txBody>
+      </p:sp>
+      <p:pic>
+        <p:nvPicPr>
+          <p:cNvPr id="5" name="Image 0" descr="preencoded.png"/>
+          <p:cNvPicPr>
+            <a:picLocks noChangeAspect="1"/>
+          </p:cNvPicPr>
+          <p:nvPr/>
+        </p:nvPicPr>
+        <p:blipFill>
+          <a:blip r:embed="rId3"/>
+          <a:srcRect l="25532" t="36305" r="33999" b="14211"/>
+          <a:stretch>
+            <a:fillRect/>
+          </a:stretch>
+        </p:blipFill>
+        <p:spPr>
+          <a:xfrm>
+            <a:off x="8072846" y="228506"/>
+            <a:ext cx="869613" cy="859724"/>
+          </a:xfrm>
+          <a:prstGeom prst="rect">
+            <a:avLst/>
+          </a:prstGeom>
+        </p:spPr>
+      </p:pic>
+      <p:sp>
+        <p:nvSpPr>
+          <p:cNvPr id="6" name="Shape 3"/>
+          <p:cNvSpPr/>
+          <p:nvPr/>
+        </p:nvSpPr>
+        <p:spPr>
+          <a:xfrm>
+            <a:off x="256032" y="256032"/>
+            <a:ext cx="2011680" cy="274320"/>
+          </a:xfrm>
+          <a:prstGeom prst="roundRect">
+            <a:avLst>
+              <a:gd name="adj" fmla="val 20000"/>
+            </a:avLst>
+          </a:prstGeom>
+          <a:solidFill>
+            <a:srgbClr val="E8F7F4"/>
+          </a:solidFill>
+          <a:ln w="12700">
+            <a:solidFill>
+              <a:srgbClr val="1C8F94"/>
+            </a:solidFill>
+            <a:prstDash val="solid"/>
+          </a:ln>
+        </p:spPr>
+        <p:txBody>
+          <a:bodyPr/>
+          <a:lstStyle/>
+          <a:p>
+            <a:endParaRPr lang="en-AU"/>
+          </a:p>
+        </p:txBody>
+      </p:sp>
+      <p:sp>
+        <p:nvSpPr>
+          <p:cNvPr id="7" name="Text 4"/>
+          <p:cNvSpPr/>
+          <p:nvPr/>
+        </p:nvSpPr>
+        <p:spPr>
+          <a:xfrm>
+            <a:off x="256032" y="256032"/>
+            <a:ext cx="2011680" cy="274320"/>
+          </a:xfrm>
+          <a:prstGeom prst="rect">
+            <a:avLst/>
+          </a:prstGeom>
+          <a:noFill/>
+          <a:ln/>
+        </p:spPr>
+        <p:txBody>
+          <a:bodyPr wrap="square" lIns="0" tIns="0" rIns="0" bIns="0" rtlCol="0" anchor="ctr"/>
+          <a:lstStyle/>
+          <a:p>
+            <a:pPr marL="0" indent="0" algn="ctr">
+              <a:buNone/>
+            </a:pPr>
+            <a:r>
+              <a:rPr lang="en-US" sz="800" b="1" kern="0" spc="150" dirty="0">
+                <a:solidFill>
+                  <a:srgbClr val="1C8F94"/>
+                </a:solidFill>
+                <a:latin typeface="Calibri" pitchFamily="34" charset="0"/>
+                <a:ea typeface="Calibri" pitchFamily="34" charset="-122"/>
+                <a:cs typeface="Calibri" pitchFamily="34" charset="-120"/>
+              </a:rPr>
+              <a:t>PRESENTATION OVERVIEW</a:t>
+            </a:r>
+            <a:endParaRPr lang="en-US" sz="800" dirty="0"/>
+          </a:p>
+        </p:txBody>
+      </p:sp>
+      <p:sp>
+        <p:nvSpPr>
+          <p:cNvPr id="8" name="Text 5"/>
+          <p:cNvSpPr/>
+          <p:nvPr/>
+        </p:nvSpPr>
+        <p:spPr>
+          <a:xfrm>
+            <a:off x="256032" y="658368"/>
+            <a:ext cx="6400800" cy="475488"/>
+          </a:xfrm>
+          <a:prstGeom prst="rect">
+            <a:avLst/>
+          </a:prstGeom>
+          <a:noFill/>
+          <a:ln/>
+        </p:spPr>
+        <p:txBody>
+          <a:bodyPr wrap="square" lIns="0" tIns="0" rIns="0" bIns="0" rtlCol="0" anchor="t"/>
+          <a:lstStyle/>
+          <a:p>
+            <a:pPr marL="0" indent="0" algn="l">
+              <a:buNone/>
+            </a:pPr>
+            <a:r>
+              <a:rPr lang="en-US" sz="2400" b="1" dirty="0">
+                <a:solidFill>
+                  <a:srgbClr val="1A1A2E"/>
+                </a:solidFill>
+                <a:latin typeface="Calibri" pitchFamily="34" charset="0"/>
+                <a:ea typeface="Calibri" pitchFamily="34" charset="-122"/>
+                <a:cs typeface="Calibri" pitchFamily="34" charset="-120"/>
+              </a:rPr>
+              <a:t>Infrastructure is Dead,</a:t>
+            </a:r>
+            <a:endParaRPr lang="en-US" sz="2400" dirty="0"/>
+          </a:p>
+        </p:txBody>
+      </p:sp>
+      <p:sp>
+        <p:nvSpPr>
+          <p:cNvPr id="9" name="Text 6"/>
+          <p:cNvSpPr/>
+          <p:nvPr/>
+        </p:nvSpPr>
+        <p:spPr>
+          <a:xfrm>
+            <a:off x="256032" y="1078992"/>
+            <a:ext cx="6400800" cy="475488"/>
+          </a:xfrm>
+          <a:prstGeom prst="rect">
+            <a:avLst/>
+          </a:prstGeom>
+          <a:noFill/>
+          <a:ln/>
+        </p:spPr>
+        <p:txBody>
+          <a:bodyPr wrap="square" lIns="0" tIns="0" rIns="0" bIns="0" rtlCol="0" anchor="t"/>
+          <a:lstStyle/>
+          <a:p>
+            <a:pPr marL="0" indent="0" algn="l">
+              <a:buNone/>
+            </a:pPr>
+            <a:r>
+              <a:rPr lang="en-US" sz="2400" b="1" dirty="0">
+                <a:solidFill>
+                  <a:srgbClr val="008BFE"/>
+                </a:solidFill>
+                <a:latin typeface="Calibri" pitchFamily="34" charset="0"/>
+                <a:ea typeface="Calibri" pitchFamily="34" charset="-122"/>
+                <a:cs typeface="Calibri" pitchFamily="34" charset="-120"/>
+              </a:rPr>
+              <a:t>Long Live Infrastructure in the Age of Agentic AI</a:t>
+            </a:r>
+            <a:endParaRPr lang="en-US" sz="2400" dirty="0"/>
+          </a:p>
+        </p:txBody>
+      </p:sp>
+      <p:sp>
+        <p:nvSpPr>
+          <p:cNvPr id="10" name="Shape 7"/>
+          <p:cNvSpPr/>
+          <p:nvPr/>
+        </p:nvSpPr>
+        <p:spPr>
+          <a:xfrm>
+            <a:off x="256032" y="1682496"/>
+            <a:ext cx="8631936" cy="0"/>
+          </a:xfrm>
+          <a:prstGeom prst="line">
+            <a:avLst/>
+          </a:prstGeom>
+          <a:noFill/>
+          <a:ln w="9525">
+            <a:solidFill>
+              <a:srgbClr val="DDDDDD"/>
+            </a:solidFill>
+            <a:prstDash val="solid"/>
+          </a:ln>
+        </p:spPr>
+        <p:txBody>
+          <a:bodyPr/>
+          <a:lstStyle/>
+          <a:p>
+            <a:endParaRPr lang="en-AU"/>
+          </a:p>
+        </p:txBody>
+      </p:sp>
+      <p:sp>
+        <p:nvSpPr>
+          <p:cNvPr id="11" name="Text 8"/>
+          <p:cNvSpPr/>
+          <p:nvPr/>
+        </p:nvSpPr>
+        <p:spPr>
+          <a:xfrm>
+            <a:off x="256032" y="1810512"/>
+            <a:ext cx="8631936" cy="2560320"/>
+          </a:xfrm>
+          <a:prstGeom prst="rect">
+            <a:avLst/>
+          </a:prstGeom>
+          <a:noFill/>
+          <a:ln/>
+        </p:spPr>
+        <p:txBody>
+          <a:bodyPr wrap="square" rtlCol="0" anchor="t"/>
+          <a:lstStyle/>
+          <a:p>
+            <a:pPr marL="0" indent="0" algn="l">
+              <a:lnSpc>
+                <a:spcPct val="145000"/>
+              </a:lnSpc>
+              <a:buNone/>
+            </a:pPr>
+            <a:r>
+              <a:rPr lang="en-US" sz="1400" dirty="0">
+                <a:solidFill>
+                  <a:srgbClr val="333333"/>
+                </a:solidFill>
+                <a:latin typeface="Calibri" pitchFamily="34" charset="0"/>
+                <a:ea typeface="Calibri" pitchFamily="34" charset="-122"/>
+                <a:cs typeface="Calibri" pitchFamily="34" charset="-120"/>
+              </a:rPr>
+              <a:t>The rise of Agentic AI is fundamentally transforming how enterprise Azure environments are architected, designed, deployed, and managed. Traditional infrastructure practices — once reliant on manual processes and static configurations — are giving way to intelligent, autonomous systems capable of making real-time decisions at scale. By integrating Agentic AI with DevOps pipelines, organisations can achieve self-optimising architectures, accelerated deployments, and continuous operational intelligence. This presentation explores how this convergence redefines the infrastructure lifecycle — shifting engineers from reactive administrators to strategic orchestrators in an increasingly autonomous, AI-driven cloud landscape.</a:t>
+            </a:r>
+            <a:endParaRPr lang="en-US" sz="1400" dirty="0"/>
+          </a:p>
+        </p:txBody>
+      </p:sp>
+      <p:sp>
+        <p:nvSpPr>
+          <p:cNvPr id="12" name="Shape 9"/>
+          <p:cNvSpPr/>
+          <p:nvPr/>
+        </p:nvSpPr>
+        <p:spPr>
+          <a:xfrm>
+            <a:off x="256032" y="4590288"/>
+            <a:ext cx="932688" cy="256032"/>
+          </a:xfrm>
+          <a:prstGeom prst="roundRect">
+            <a:avLst>
+              <a:gd name="adj" fmla="val 21429"/>
+            </a:avLst>
+          </a:prstGeom>
+          <a:solidFill>
+            <a:srgbClr val="E8F7F4"/>
+          </a:solidFill>
+          <a:ln w="12700">
+            <a:solidFill>
+              <a:srgbClr val="1C8F94"/>
+            </a:solidFill>
+            <a:prstDash val="solid"/>
+          </a:ln>
+        </p:spPr>
+        <p:txBody>
+          <a:bodyPr/>
+          <a:lstStyle/>
+          <a:p>
+            <a:endParaRPr lang="en-AU"/>
+          </a:p>
+        </p:txBody>
+      </p:sp>
+      <p:sp>
+        <p:nvSpPr>
+          <p:cNvPr id="13" name="Text 10"/>
+          <p:cNvSpPr/>
+          <p:nvPr/>
+        </p:nvSpPr>
+        <p:spPr>
+          <a:xfrm>
+            <a:off x="256032" y="4590288"/>
+            <a:ext cx="932688" cy="256032"/>
+          </a:xfrm>
+          <a:prstGeom prst="rect">
+            <a:avLst/>
+          </a:prstGeom>
+          <a:noFill/>
+          <a:ln/>
+        </p:spPr>
+        <p:txBody>
+          <a:bodyPr wrap="square" lIns="0" tIns="0" rIns="0" bIns="0" rtlCol="0" anchor="ctr"/>
+          <a:lstStyle/>
+          <a:p>
+            <a:pPr marL="0" indent="0" algn="ctr">
+              <a:buNone/>
+            </a:pPr>
+            <a:r>
+              <a:rPr lang="en-US" sz="750" b="1" dirty="0">
+                <a:solidFill>
+                  <a:srgbClr val="1C8F94"/>
+                </a:solidFill>
+                <a:latin typeface="Calibri" pitchFamily="34" charset="0"/>
+                <a:ea typeface="Calibri" pitchFamily="34" charset="-122"/>
+                <a:cs typeface="Calibri" pitchFamily="34" charset="-120"/>
+              </a:rPr>
+              <a:t>Agentic AI</a:t>
+            </a:r>
+            <a:endParaRPr lang="en-US" sz="750" dirty="0"/>
+          </a:p>
+        </p:txBody>
+      </p:sp>
+      <p:sp>
+        <p:nvSpPr>
+          <p:cNvPr id="14" name="Shape 11"/>
+          <p:cNvSpPr/>
+          <p:nvPr/>
+        </p:nvSpPr>
+        <p:spPr>
+          <a:xfrm>
+            <a:off x="1316736" y="4590288"/>
+            <a:ext cx="694944" cy="256032"/>
+          </a:xfrm>
+          <a:prstGeom prst="roundRect">
+            <a:avLst>
+              <a:gd name="adj" fmla="val 21429"/>
+            </a:avLst>
+          </a:prstGeom>
+          <a:solidFill>
+            <a:srgbClr val="E8F4FF"/>
+          </a:solidFill>
+          <a:ln w="12700">
+            <a:solidFill>
+              <a:srgbClr val="008BFE"/>
+            </a:solidFill>
+            <a:prstDash val="solid"/>
+          </a:ln>
+        </p:spPr>
+        <p:txBody>
+          <a:bodyPr/>
+          <a:lstStyle/>
+          <a:p>
+            <a:endParaRPr lang="en-AU"/>
+          </a:p>
+        </p:txBody>
+      </p:sp>
+      <p:sp>
+        <p:nvSpPr>
+          <p:cNvPr id="15" name="Text 12"/>
+          <p:cNvSpPr/>
+          <p:nvPr/>
+        </p:nvSpPr>
+        <p:spPr>
+          <a:xfrm>
+            <a:off x="1316736" y="4590288"/>
+            <a:ext cx="694944" cy="256032"/>
+          </a:xfrm>
+          <a:prstGeom prst="rect">
+            <a:avLst/>
+          </a:prstGeom>
+          <a:noFill/>
+          <a:ln/>
+        </p:spPr>
+        <p:txBody>
+          <a:bodyPr wrap="square" lIns="0" tIns="0" rIns="0" bIns="0" rtlCol="0" anchor="ctr"/>
+          <a:lstStyle/>
+          <a:p>
+            <a:pPr marL="0" indent="0" algn="ctr">
+              <a:buNone/>
+            </a:pPr>
+            <a:r>
+              <a:rPr lang="en-US" sz="750" b="1" dirty="0">
+                <a:solidFill>
+                  <a:srgbClr val="008BFE"/>
+                </a:solidFill>
+                <a:latin typeface="Calibri" pitchFamily="34" charset="0"/>
+                <a:ea typeface="Calibri" pitchFamily="34" charset="-122"/>
+                <a:cs typeface="Calibri" pitchFamily="34" charset="-120"/>
+              </a:rPr>
+              <a:t>Azure</a:t>
+            </a:r>
+            <a:endParaRPr lang="en-US" sz="750" dirty="0"/>
+          </a:p>
+        </p:txBody>
+      </p:sp>
+      <p:sp>
+        <p:nvSpPr>
+          <p:cNvPr id="16" name="Shape 13"/>
+          <p:cNvSpPr/>
+          <p:nvPr/>
+        </p:nvSpPr>
+        <p:spPr>
+          <a:xfrm>
+            <a:off x="2139696" y="4590288"/>
+            <a:ext cx="786384" cy="256032"/>
+          </a:xfrm>
+          <a:prstGeom prst="roundRect">
+            <a:avLst>
+              <a:gd name="adj" fmla="val 21429"/>
+            </a:avLst>
+          </a:prstGeom>
+          <a:solidFill>
+            <a:srgbClr val="E8F7F4"/>
+          </a:solidFill>
+          <a:ln w="12700">
+            <a:solidFill>
+              <a:srgbClr val="1C8F94"/>
+            </a:solidFill>
+            <a:prstDash val="solid"/>
+          </a:ln>
+        </p:spPr>
+        <p:txBody>
+          <a:bodyPr/>
+          <a:lstStyle/>
+          <a:p>
+            <a:endParaRPr lang="en-AU"/>
+          </a:p>
+        </p:txBody>
+      </p:sp>
+      <p:sp>
+        <p:nvSpPr>
+          <p:cNvPr id="17" name="Text 14"/>
+          <p:cNvSpPr/>
+          <p:nvPr/>
+        </p:nvSpPr>
+        <p:spPr>
+          <a:xfrm>
+            <a:off x="2139696" y="4590288"/>
+            <a:ext cx="786384" cy="256032"/>
+          </a:xfrm>
+          <a:prstGeom prst="rect">
+            <a:avLst/>
+          </a:prstGeom>
+          <a:noFill/>
+          <a:ln/>
+        </p:spPr>
+        <p:txBody>
+          <a:bodyPr wrap="square" lIns="0" tIns="0" rIns="0" bIns="0" rtlCol="0" anchor="ctr"/>
+          <a:lstStyle/>
+          <a:p>
+            <a:pPr marL="0" indent="0" algn="ctr">
+              <a:buNone/>
+            </a:pPr>
+            <a:r>
+              <a:rPr lang="en-US" sz="750" b="1" dirty="0">
+                <a:solidFill>
+                  <a:srgbClr val="1C8F94"/>
+                </a:solidFill>
+                <a:latin typeface="Calibri" pitchFamily="34" charset="0"/>
+                <a:ea typeface="Calibri" pitchFamily="34" charset="-122"/>
+                <a:cs typeface="Calibri" pitchFamily="34" charset="-120"/>
+              </a:rPr>
+              <a:t>DevOps</a:t>
+            </a:r>
+            <a:endParaRPr lang="en-US" sz="750" dirty="0"/>
+          </a:p>
+        </p:txBody>
+      </p:sp>
+      <p:sp>
+        <p:nvSpPr>
+          <p:cNvPr id="18" name="Shape 15"/>
+          <p:cNvSpPr/>
+          <p:nvPr/>
+        </p:nvSpPr>
+        <p:spPr>
+          <a:xfrm>
+            <a:off x="3054096" y="4590288"/>
+            <a:ext cx="1325880" cy="256032"/>
+          </a:xfrm>
+          <a:prstGeom prst="roundRect">
+            <a:avLst>
+              <a:gd name="adj" fmla="val 21429"/>
+            </a:avLst>
+          </a:prstGeom>
+          <a:solidFill>
+            <a:srgbClr val="E8F4FF"/>
+          </a:solidFill>
+          <a:ln w="12700">
+            <a:solidFill>
+              <a:srgbClr val="008BFE"/>
+            </a:solidFill>
+            <a:prstDash val="solid"/>
+          </a:ln>
+        </p:spPr>
+        <p:txBody>
+          <a:bodyPr/>
+          <a:lstStyle/>
+          <a:p>
+            <a:endParaRPr lang="en-AU"/>
+          </a:p>
+        </p:txBody>
+      </p:sp>
+      <p:sp>
+        <p:nvSpPr>
+          <p:cNvPr id="19" name="Text 16"/>
+          <p:cNvSpPr/>
+          <p:nvPr/>
+        </p:nvSpPr>
+        <p:spPr>
+          <a:xfrm>
+            <a:off x="3054096" y="4590288"/>
+            <a:ext cx="1325880" cy="256032"/>
+          </a:xfrm>
+          <a:prstGeom prst="rect">
+            <a:avLst/>
+          </a:prstGeom>
+          <a:noFill/>
+          <a:ln/>
+        </p:spPr>
+        <p:txBody>
+          <a:bodyPr wrap="square" lIns="0" tIns="0" rIns="0" bIns="0" rtlCol="0" anchor="ctr"/>
+          <a:lstStyle/>
+          <a:p>
+            <a:pPr marL="0" indent="0" algn="ctr">
+              <a:buNone/>
+            </a:pPr>
+            <a:r>
+              <a:rPr lang="en-US" sz="750" b="1" dirty="0">
+                <a:solidFill>
+                  <a:srgbClr val="008BFE"/>
+                </a:solidFill>
+                <a:latin typeface="Calibri" pitchFamily="34" charset="0"/>
+                <a:ea typeface="Calibri" pitchFamily="34" charset="-122"/>
+                <a:cs typeface="Calibri" pitchFamily="34" charset="-120"/>
+              </a:rPr>
+              <a:t>Enterprise Cloud</a:t>
+            </a:r>
+            <a:endParaRPr lang="en-US" sz="750" dirty="0"/>
+          </a:p>
+        </p:txBody>
+      </p:sp>
+      <p:sp>
+        <p:nvSpPr>
+          <p:cNvPr id="20" name="Shape 17"/>
+          <p:cNvSpPr/>
+          <p:nvPr/>
+        </p:nvSpPr>
+        <p:spPr>
+          <a:xfrm>
+            <a:off x="4507992" y="4590288"/>
+            <a:ext cx="1115568" cy="256032"/>
+          </a:xfrm>
+          <a:prstGeom prst="roundRect">
+            <a:avLst>
+              <a:gd name="adj" fmla="val 21429"/>
+            </a:avLst>
+          </a:prstGeom>
+          <a:solidFill>
+            <a:srgbClr val="E8F7F4"/>
+          </a:solidFill>
+          <a:ln w="12700">
+            <a:solidFill>
+              <a:srgbClr val="1C8F94"/>
+            </a:solidFill>
+            <a:prstDash val="solid"/>
+          </a:ln>
+        </p:spPr>
+        <p:txBody>
+          <a:bodyPr/>
+          <a:lstStyle/>
+          <a:p>
+            <a:endParaRPr lang="en-AU"/>
+          </a:p>
+        </p:txBody>
+      </p:sp>
+      <p:sp>
+        <p:nvSpPr>
+          <p:cNvPr id="21" name="Text 18"/>
+          <p:cNvSpPr/>
+          <p:nvPr/>
+        </p:nvSpPr>
+        <p:spPr>
+          <a:xfrm>
+            <a:off x="4507992" y="4590288"/>
+            <a:ext cx="1115568" cy="256032"/>
+          </a:xfrm>
+          <a:prstGeom prst="rect">
+            <a:avLst/>
+          </a:prstGeom>
+          <a:noFill/>
+          <a:ln/>
+        </p:spPr>
+        <p:txBody>
+          <a:bodyPr wrap="square" lIns="0" tIns="0" rIns="0" bIns="0" rtlCol="0" anchor="ctr"/>
+          <a:lstStyle/>
+          <a:p>
+            <a:pPr marL="0" indent="0" algn="ctr">
+              <a:buNone/>
+            </a:pPr>
+            <a:r>
+              <a:rPr lang="en-US" sz="750" b="1" dirty="0">
+                <a:solidFill>
+                  <a:srgbClr val="1C8F94"/>
+                </a:solidFill>
+                <a:latin typeface="Calibri" pitchFamily="34" charset="0"/>
+                <a:ea typeface="Calibri" pitchFamily="34" charset="-122"/>
+                <a:cs typeface="Calibri" pitchFamily="34" charset="-120"/>
+              </a:rPr>
+              <a:t>Infrastructure</a:t>
+            </a:r>
+            <a:endParaRPr lang="en-US" sz="750" dirty="0"/>
+          </a:p>
+        </p:txBody>
+      </p:sp>
+      <p:sp>
+        <p:nvSpPr>
+          <p:cNvPr id="22" name="Text 19"/>
+          <p:cNvSpPr/>
+          <p:nvPr/>
+        </p:nvSpPr>
+        <p:spPr>
+          <a:xfrm>
+            <a:off x="5934456" y="4608576"/>
+            <a:ext cx="2935224" cy="237744"/>
+          </a:xfrm>
+          <a:prstGeom prst="rect">
+            <a:avLst/>
+          </a:prstGeom>
+          <a:noFill/>
+          <a:ln/>
+        </p:spPr>
+        <p:txBody>
+          <a:bodyPr wrap="square" lIns="0" tIns="0" rIns="0" bIns="0" rtlCol="0" anchor="ctr"/>
+          <a:lstStyle/>
+          <a:p>
+            <a:pPr marL="0" indent="0" algn="r">
+              <a:buNone/>
+            </a:pPr>
+            <a:r>
+              <a:rPr lang="en-US" sz="750" i="1" dirty="0">
+                <a:solidFill>
+                  <a:srgbClr val="BBBBBB"/>
+                </a:solidFill>
+                <a:latin typeface="Calibri" pitchFamily="34" charset="0"/>
+                <a:ea typeface="Calibri" pitchFamily="34" charset="-122"/>
+                <a:cs typeface="Calibri" pitchFamily="34" charset="-120"/>
+              </a:rPr>
+              <a:t>Cloud Paradigm Pty Ltd  |  cloudparadigm.com.au</a:t>
+            </a:r>
+            <a:endParaRPr lang="en-US" sz="750" dirty="0"/>
+          </a:p>
+        </p:txBody>
+      </p:sp>
+    </p:spTree>
+  </p:cSld>
+  <p:clrMapOvr>
+    <a:masterClrMapping/>
+  </p:clrMapOvr>
+</p:sld>
+</file>
+
 <file path=ppt/slides/slide3.xml><?xml version="1.0" encoding="utf-8"?>
 <p:sld xmlns:a="http://schemas.openxmlformats.org/drawingml/2006/main" xmlns:r="http://schemas.openxmlformats.org/officeDocument/2006/relationships" xmlns:p="http://schemas.openxmlformats.org/presentationml/2006/main">
   <p:cSld name="Slide 3">

</xml_diff>

<commit_message>
Add demo architecture diagram slide (from whiteboard sketch) — deck now 23 slides
</commit_message>
<xml_diff>
--- a/presentation/cloud_paradigm_presentation_v3.pptx
+++ b/presentation/cloud_paradigm_presentation_v3.pptx
@@ -19,6 +19,7 @@
     <p:sldId id="264" r:id="rId17"/>
     <p:sldId id="265" r:id="rId18"/>
     <p:sldId id="266" r:id="rId19"/>
+    <p:sldId id="278" r:id="rId31"/>
     <p:sldId id="267" r:id="rId20"/>
     <p:sldId id="268" r:id="rId21"/>
     <p:sldId id="269" r:id="rId22"/>
@@ -11375,6 +11376,1083 @@
 </p:sld>
 </file>
 
+<file path=ppt/slides/slide23.xml><?xml version="1.0" encoding="utf-8"?>
+<p:sld xmlns:a="http://schemas.openxmlformats.org/drawingml/2006/main" xmlns:r="http://schemas.openxmlformats.org/officeDocument/2006/relationships" xmlns:p="http://schemas.openxmlformats.org/presentationml/2006/main">
+  <p:cSld name="Demo Architecture">
+    <p:bg>
+      <p:bgPr>
+        <a:solidFill>
+          <a:srgbClr val="FFFFFF"/>
+        </a:solidFill>
+        <a:effectLst/>
+      </p:bgPr>
+    </p:bg>
+    <p:spTree>
+      <p:nvGrpSpPr>
+        <p:cNvPr id="1" name=""/>
+        <p:cNvGrpSpPr/>
+        <p:nvPr/>
+      </p:nvGrpSpPr>
+      <p:grpSpPr>
+        <a:xfrm>
+          <a:off x="0" y="0"/>
+          <a:ext cx="0" cy="0"/>
+          <a:chOff x="0" y="0"/>
+          <a:chExt cx="0" cy="0"/>
+        </a:xfrm>
+      </p:grpSpPr>
+      <p:sp>
+        <p:nvSpPr>
+          <p:cNvPr id="2" name="TopBar"/>
+          <p:cNvSpPr/>
+          <p:nvPr/>
+        </p:nvSpPr>
+        <p:spPr>
+          <a:xfrm>
+            <a:off x="0" y="0"/>
+            <a:ext cx="9144000" cy="164592"/>
+          </a:xfrm>
+          <a:prstGeom prst="rect">
+            <a:avLst/>
+          </a:prstGeom>
+          <a:solidFill>
+            <a:srgbClr val="1C8F94"/>
+          </a:solidFill>
+          <a:ln w="12700">
+            <a:solidFill>
+              <a:srgbClr val="1C8F94"/>
+            </a:solidFill>
+            <a:prstDash val="solid"/>
+          </a:ln>
+        </p:spPr>
+        <p:txBody>
+          <a:bodyPr/>
+          <a:lstStyle/>
+          <a:p>
+            <a:endParaRPr lang="en-AU"/>
+          </a:p>
+        </p:txBody>
+      </p:sp>
+      <p:sp>
+        <p:nvSpPr>
+          <p:cNvPr id="3" name="BotBar"/>
+          <p:cNvSpPr/>
+          <p:nvPr/>
+        </p:nvSpPr>
+        <p:spPr>
+          <a:xfrm>
+            <a:off x="0" y="4983480"/>
+            <a:ext cx="9144000" cy="164592"/>
+          </a:xfrm>
+          <a:prstGeom prst="rect">
+            <a:avLst/>
+          </a:prstGeom>
+          <a:solidFill>
+            <a:srgbClr val="008BFE"/>
+          </a:solidFill>
+          <a:ln w="12700">
+            <a:solidFill>
+              <a:srgbClr val="008BFE"/>
+            </a:solidFill>
+            <a:prstDash val="solid"/>
+          </a:ln>
+        </p:spPr>
+        <p:txBody>
+          <a:bodyPr/>
+          <a:lstStyle/>
+          <a:p>
+            <a:endParaRPr lang="en-AU"/>
+          </a:p>
+        </p:txBody>
+      </p:sp>
+      <p:sp>
+        <p:nvSpPr>
+          <p:cNvPr id="4" name="LeftBar"/>
+          <p:cNvSpPr/>
+          <p:nvPr/>
+        </p:nvSpPr>
+        <p:spPr>
+          <a:xfrm>
+            <a:off x="0" y="164592"/>
+            <a:ext cx="128016" cy="4809744"/>
+          </a:xfrm>
+          <a:prstGeom prst="rect">
+            <a:avLst/>
+          </a:prstGeom>
+          <a:solidFill>
+            <a:srgbClr val="259D77"/>
+          </a:solidFill>
+          <a:ln w="12700">
+            <a:solidFill>
+              <a:srgbClr val="259D77"/>
+            </a:solidFill>
+            <a:prstDash val="solid"/>
+          </a:ln>
+        </p:spPr>
+        <p:txBody>
+          <a:bodyPr/>
+          <a:lstStyle/>
+          <a:p>
+            <a:endParaRPr lang="en-AU"/>
+          </a:p>
+        </p:txBody>
+      </p:sp>
+      <p:pic>
+        <p:nvPicPr>
+          <p:cNvPr id="5" name="Logo" descr="preencoded.png"/>
+          <p:cNvPicPr>
+            <a:picLocks noChangeAspect="1"/>
+          </p:cNvPicPr>
+          <p:nvPr/>
+        </p:nvPicPr>
+        <p:blipFill>
+          <a:blip r:embed="rId3"/>
+          <a:srcRect l="25532" t="36305" r="33999" b="14211"/>
+          <a:stretch>
+            <a:fillRect/>
+          </a:stretch>
+        </p:blipFill>
+        <p:spPr>
+          <a:xfrm>
+            <a:off x="8072846" y="228506"/>
+            <a:ext cx="869613" cy="859724"/>
+          </a:xfrm>
+          <a:prstGeom prst="rect">
+            <a:avLst/>
+          </a:prstGeom>
+        </p:spPr>
+      </p:pic>
+      <p:sp>
+        <p:nvSpPr>
+          <p:cNvPr id="6" name="BadgeBg"/>
+          <p:cNvSpPr/>
+          <p:nvPr/>
+        </p:nvSpPr>
+        <p:spPr>
+          <a:xfrm>
+            <a:off x="256032" y="256032"/>
+            <a:ext cx="1950000" cy="274320"/>
+          </a:xfrm>
+          <a:prstGeom prst="roundRect">
+            <a:avLst>
+              <a:gd name="adj" fmla="val 20000"/>
+            </a:avLst>
+          </a:prstGeom>
+          <a:solidFill>
+            <a:srgbClr val="E8F7F4"/>
+          </a:solidFill>
+          <a:ln w="12700">
+            <a:solidFill>
+              <a:srgbClr val="1C8F94"/>
+            </a:solidFill>
+            <a:prstDash val="solid"/>
+          </a:ln>
+        </p:spPr>
+        <p:txBody>
+          <a:bodyPr/>
+          <a:lstStyle/>
+          <a:p>
+            <a:endParaRPr lang="en-AU"/>
+          </a:p>
+        </p:txBody>
+      </p:sp>
+      <p:sp>
+        <p:nvSpPr>
+          <p:cNvPr id="7" name="BadgeText"/>
+          <p:cNvSpPr/>
+          <p:nvPr/>
+        </p:nvSpPr>
+        <p:spPr>
+          <a:xfrm>
+            <a:off x="256032" y="256032"/>
+            <a:ext cx="1950000" cy="274320"/>
+          </a:xfrm>
+          <a:prstGeom prst="rect">
+            <a:avLst/>
+          </a:prstGeom>
+          <a:noFill/>
+          <a:ln/>
+        </p:spPr>
+        <p:txBody>
+          <a:bodyPr wrap="square" lIns="0" tIns="0" rIns="0" bIns="0" rtlCol="0" anchor="ctr"/>
+          <a:lstStyle/>
+          <a:p>
+            <a:pPr marL="0" indent="0" algn="ctr">
+              <a:buNone/>
+            </a:pPr>
+            <a:r>
+              <a:rPr lang="en-US" sz="800" b="1" kern="0" spc="150" dirty="0">
+                <a:solidFill>
+                  <a:srgbClr val="1C8F94"/>
+                </a:solidFill>
+                <a:latin typeface="Calibri" pitchFamily="34" charset="0"/>
+              </a:rPr>
+              <a:t>LIVE DEMO</a:t>
+            </a:r>
+          </a:p>
+        </p:txBody>
+      </p:sp>
+      <p:sp>
+        <p:nvSpPr>
+          <p:cNvPr id="8" name="Title"/>
+          <p:cNvSpPr/>
+          <p:nvPr/>
+        </p:nvSpPr>
+        <p:spPr>
+          <a:xfrm>
+            <a:off x="256032" y="600000"/>
+            <a:ext cx="7800000" cy="380000"/>
+          </a:xfrm>
+          <a:prstGeom prst="rect">
+            <a:avLst/>
+          </a:prstGeom>
+          <a:noFill/>
+          <a:ln/>
+        </p:spPr>
+        <p:txBody>
+          <a:bodyPr wrap="square" lIns="0" tIns="0" rIns="0" bIns="0" rtlCol="0" anchor="t"/>
+          <a:lstStyle/>
+          <a:p>
+            <a:pPr marL="0" indent="0" algn="l">
+              <a:buNone/>
+            </a:pPr>
+            <a:r>
+              <a:rPr lang="en-US" sz="2400" b="1" dirty="0">
+                <a:solidFill>
+                  <a:srgbClr val="1A1A2E"/>
+                </a:solidFill>
+                <a:latin typeface="Calibri" pitchFamily="34" charset="0"/>
+              </a:rPr>
+              <a:t>Demo Architecture</a:t>
+            </a:r>
+          </a:p>
+        </p:txBody>
+      </p:sp>
+      <p:sp>
+        <p:nvSpPr>
+          <p:cNvPr id="9" name="Subtitle"/>
+          <p:cNvSpPr/>
+          <p:nvPr/>
+        </p:nvSpPr>
+        <p:spPr>
+          <a:xfrm>
+            <a:off x="256032" y="980000"/>
+            <a:ext cx="7800000" cy="300000"/>
+          </a:xfrm>
+          <a:prstGeom prst="rect">
+            <a:avLst/>
+          </a:prstGeom>
+          <a:noFill/>
+          <a:ln/>
+        </p:spPr>
+        <p:txBody>
+          <a:bodyPr wrap="square" lIns="0" tIns="0" rIns="0" bIns="0" rtlCol="0" anchor="t"/>
+          <a:lstStyle/>
+          <a:p>
+            <a:pPr marL="0" indent="0" algn="l">
+              <a:buNone/>
+            </a:pPr>
+            <a:r>
+              <a:rPr lang="en-US" sz="1600" b="1" dirty="0">
+                <a:solidFill>
+                  <a:srgbClr val="008BFE"/>
+                </a:solidFill>
+                <a:latin typeface="Calibri" pitchFamily="34" charset="0"/>
+              </a:rPr>
+              <a:t>Claude + GitHub Codespaces + Azure Environment</a:t>
+            </a:r>
+          </a:p>
+        </p:txBody>
+      </p:sp>
+      <p:sp>
+        <p:nvSpPr>
+          <p:cNvPr id="10" name="Divider"/>
+          <p:cNvSpPr/>
+          <p:nvPr/>
+        </p:nvSpPr>
+        <p:spPr>
+          <a:xfrm>
+            <a:off x="256032" y="1330000"/>
+            <a:ext cx="8631936" cy="0"/>
+          </a:xfrm>
+          <a:prstGeom prst="line">
+            <a:avLst/>
+          </a:prstGeom>
+          <a:noFill/>
+          <a:ln w="9525">
+            <a:solidFill>
+              <a:srgbClr val="DDDDDD"/>
+            </a:solidFill>
+            <a:prstDash val="solid"/>
+          </a:ln>
+        </p:spPr>
+        <p:txBody>
+          <a:bodyPr/>
+          <a:lstStyle/>
+          <a:p>
+            <a:endParaRPr lang="en-AU"/>
+          </a:p>
+        </p:txBody>
+      </p:sp>
+      <p:sp>
+        <p:nvSpPr>
+          <p:cNvPr id="20" name="ClaudeBox"/>
+          <p:cNvSpPr/>
+          <p:nvPr/>
+        </p:nvSpPr>
+        <p:spPr>
+          <a:xfrm>
+            <a:off x="256032" y="1420000"/>
+            <a:ext cx="2300000" cy="2150000"/>
+          </a:xfrm>
+          <a:prstGeom prst="roundRect">
+            <a:avLst>
+              <a:gd name="adj" fmla="val 5000"/>
+            </a:avLst>
+          </a:prstGeom>
+          <a:solidFill>
+            <a:srgbClr val="E8F7F4"/>
+          </a:solidFill>
+          <a:ln w="28000">
+            <a:solidFill>
+              <a:srgbClr val="1C8F94"/>
+            </a:solidFill>
+            <a:prstDash val="solid"/>
+          </a:ln>
+        </p:spPr>
+        <p:txBody>
+          <a:bodyPr/>
+          <a:lstStyle/>
+          <a:p>
+            <a:endParaRPr lang="en-AU"/>
+          </a:p>
+        </p:txBody>
+      </p:sp>
+      <p:sp>
+        <p:nvSpPr>
+          <p:cNvPr id="21" name="ClaudeLabel"/>
+          <p:cNvSpPr/>
+          <p:nvPr/>
+        </p:nvSpPr>
+        <p:spPr>
+          <a:xfrm>
+            <a:off x="256032" y="1450000"/>
+            <a:ext cx="2300000" cy="300000"/>
+          </a:xfrm>
+          <a:prstGeom prst="rect">
+            <a:avLst/>
+          </a:prstGeom>
+          <a:noFill/>
+          <a:ln/>
+        </p:spPr>
+        <p:txBody>
+          <a:bodyPr wrap="square" lIns="0" tIns="0" rIns="0" bIns="0" rtlCol="0" anchor="ctr"/>
+          <a:lstStyle/>
+          <a:p>
+            <a:pPr marL="0" indent="0" algn="ctr">
+              <a:buNone/>
+            </a:pPr>
+            <a:r>
+              <a:rPr lang="en-US" sz="1600" b="1" dirty="0">
+                <a:solidFill>
+                  <a:srgbClr val="1C8F94"/>
+                </a:solidFill>
+                <a:latin typeface="Calibri" pitchFamily="34" charset="0"/>
+              </a:rPr>
+              <a:t>CLAUDE</a:t>
+            </a:r>
+          </a:p>
+        </p:txBody>
+      </p:sp>
+      <p:sp>
+        <p:nvSpPr>
+          <p:cNvPr id="22" name="ClaudeIcon"/>
+          <p:cNvSpPr/>
+          <p:nvPr/>
+        </p:nvSpPr>
+        <p:spPr>
+          <a:xfrm>
+            <a:off x="806032" y="1780000"/>
+            <a:ext cx="1200000" cy="1200000"/>
+          </a:xfrm>
+          <a:prstGeom prst="ellipse">
+            <a:avLst/>
+          </a:prstGeom>
+          <a:solidFill>
+            <a:srgbClr val="1C8F94"/>
+          </a:solidFill>
+          <a:ln w="12700">
+            <a:solidFill>
+              <a:srgbClr val="1C8F94"/>
+            </a:solidFill>
+          </a:ln>
+        </p:spPr>
+        <p:txBody>
+          <a:bodyPr wrap="square" lIns="0" tIns="0" rIns="0" bIns="0" rtlCol="0" anchor="ctr"/>
+          <a:lstStyle/>
+          <a:p>
+            <a:pPr marL="0" indent="0" algn="ctr">
+              <a:buNone/>
+            </a:pPr>
+            <a:r>
+              <a:rPr lang="en-US" sz="5600" b="1" dirty="0">
+                <a:solidFill>
+                  <a:srgbClr val="FFFFFF"/>
+                </a:solidFill>
+                <a:latin typeface="Calibri" pitchFamily="34" charset="0"/>
+              </a:rPr>
+              <a:t>C</a:t>
+            </a:r>
+          </a:p>
+        </p:txBody>
+      </p:sp>
+      <p:sp>
+        <p:nvSpPr>
+          <p:cNvPr id="23" name="ClaudeSub"/>
+          <p:cNvSpPr/>
+          <p:nvPr/>
+        </p:nvSpPr>
+        <p:spPr>
+          <a:xfrm>
+            <a:off x="256032" y="3070000"/>
+            <a:ext cx="2300000" cy="280000"/>
+          </a:xfrm>
+          <a:prstGeom prst="rect">
+            <a:avLst/>
+          </a:prstGeom>
+          <a:noFill/>
+          <a:ln/>
+        </p:spPr>
+        <p:txBody>
+          <a:bodyPr wrap="square" lIns="0" tIns="0" rIns="0" bIns="0" rtlCol="0" anchor="ctr"/>
+          <a:lstStyle/>
+          <a:p>
+            <a:pPr marL="0" indent="0" algn="ctr">
+              <a:buNone/>
+            </a:pPr>
+            <a:r>
+              <a:rPr lang="en-US" sz="1000" dirty="0">
+                <a:solidFill>
+                  <a:srgbClr val="555555"/>
+                </a:solidFill>
+                <a:latin typeface="Calibri" pitchFamily="34" charset="0"/>
+              </a:rPr>
+              <a:t>AI Agent / claude.ai</a:t>
+            </a:r>
+          </a:p>
+        </p:txBody>
+      </p:sp>
+      <p:sp>
+        <p:nvSpPr>
+          <p:cNvPr id="30" name="Arrow1"/>
+          <p:cNvSpPr/>
+          <p:nvPr/>
+        </p:nvSpPr>
+        <p:spPr>
+          <a:xfrm>
+            <a:off x="2600000" y="2380000"/>
+            <a:ext cx="380000" cy="210000"/>
+          </a:xfrm>
+          <a:prstGeom prst="rightArrow">
+            <a:avLst>
+              <a:gd name="adj1" fmla="val 50000"/>
+              <a:gd name="adj2" fmla="val 60000"/>
+            </a:avLst>
+          </a:prstGeom>
+          <a:solidFill>
+            <a:srgbClr val="1C8F94"/>
+          </a:solidFill>
+          <a:ln w="12700">
+            <a:solidFill>
+              <a:srgbClr val="1C8F94"/>
+            </a:solidFill>
+          </a:ln>
+        </p:spPr>
+        <p:txBody>
+          <a:bodyPr/>
+          <a:lstStyle/>
+          <a:p>
+            <a:endParaRPr lang="en-AU"/>
+          </a:p>
+        </p:txBody>
+      </p:sp>
+      <p:sp>
+        <p:nvSpPr>
+          <p:cNvPr id="40" name="GithubBox"/>
+          <p:cNvSpPr/>
+          <p:nvPr/>
+        </p:nvSpPr>
+        <p:spPr>
+          <a:xfrm>
+            <a:off x="3010000" y="1420000"/>
+            <a:ext cx="2650000" cy="2150000"/>
+          </a:xfrm>
+          <a:prstGeom prst="roundRect">
+            <a:avLst>
+              <a:gd name="adj" fmla="val 5000"/>
+            </a:avLst>
+          </a:prstGeom>
+          <a:solidFill>
+            <a:srgbClr val="E8F4FF"/>
+          </a:solidFill>
+          <a:ln w="28000">
+            <a:solidFill>
+              <a:srgbClr val="008BFE"/>
+            </a:solidFill>
+            <a:prstDash val="solid"/>
+          </a:ln>
+        </p:spPr>
+        <p:txBody>
+          <a:bodyPr/>
+          <a:lstStyle/>
+          <a:p>
+            <a:endParaRPr lang="en-AU"/>
+          </a:p>
+        </p:txBody>
+      </p:sp>
+      <p:sp>
+        <p:nvSpPr>
+          <p:cNvPr id="41" name="GithubLabel"/>
+          <p:cNvSpPr/>
+          <p:nvPr/>
+        </p:nvSpPr>
+        <p:spPr>
+          <a:xfrm>
+            <a:off x="3010000" y="1450000"/>
+            <a:ext cx="2650000" cy="300000"/>
+          </a:xfrm>
+          <a:prstGeom prst="rect">
+            <a:avLst/>
+          </a:prstGeom>
+          <a:noFill/>
+          <a:ln/>
+        </p:spPr>
+        <p:txBody>
+          <a:bodyPr wrap="square" lIns="0" tIns="0" rIns="0" bIns="0" rtlCol="0" anchor="ctr"/>
+          <a:lstStyle/>
+          <a:p>
+            <a:pPr marL="0" indent="0" algn="ctr">
+              <a:buNone/>
+            </a:pPr>
+            <a:r>
+              <a:rPr lang="en-US" sz="1600" b="1" dirty="0">
+                <a:solidFill>
+                  <a:srgbClr val="008BFE"/>
+                </a:solidFill>
+                <a:latin typeface="Calibri" pitchFamily="34" charset="0"/>
+              </a:rPr>
+              <a:t>GITHUB</a:t>
+            </a:r>
+          </a:p>
+        </p:txBody>
+      </p:sp>
+      <p:sp>
+        <p:nvSpPr>
+          <p:cNvPr id="42" name="RepoBox"/>
+          <p:cNvSpPr/>
+          <p:nvPr/>
+        </p:nvSpPr>
+        <p:spPr>
+          <a:xfrm>
+            <a:off x="3110000" y="1810000"/>
+            <a:ext cx="1100000" cy="480000"/>
+          </a:xfrm>
+          <a:prstGeom prst="roundRect">
+            <a:avLst>
+              <a:gd name="adj" fmla="val 8000"/>
+            </a:avLst>
+          </a:prstGeom>
+          <a:solidFill>
+            <a:srgbClr val="FFFFFF"/>
+          </a:solidFill>
+          <a:ln w="19000">
+            <a:solidFill>
+              <a:srgbClr val="008BFE"/>
+            </a:solidFill>
+            <a:prstDash val="solid"/>
+          </a:ln>
+        </p:spPr>
+        <p:txBody>
+          <a:bodyPr wrap="square" lIns="0" tIns="0" rIns="0" bIns="0" rtlCol="0" anchor="ctr"/>
+          <a:lstStyle/>
+          <a:p>
+            <a:pPr marL="0" indent="0" algn="ctr">
+              <a:buNone/>
+            </a:pPr>
+            <a:r>
+              <a:rPr lang="en-US" sz="1100" b="1" dirty="0">
+                <a:solidFill>
+                  <a:srgbClr val="008BFE"/>
+                </a:solidFill>
+                <a:latin typeface="Calibri" pitchFamily="34" charset="0"/>
+              </a:rPr>
+              <a:t>Repo</a:t>
+            </a:r>
+          </a:p>
+        </p:txBody>
+      </p:sp>
+      <p:sp>
+        <p:nvSpPr>
+          <p:cNvPr id="43" name="CodespacesBox"/>
+          <p:cNvSpPr/>
+          <p:nvPr/>
+        </p:nvSpPr>
+        <p:spPr>
+          <a:xfrm>
+            <a:off x="4360000" y="1810000"/>
+            <a:ext cx="1200000" cy="480000"/>
+          </a:xfrm>
+          <a:prstGeom prst="roundRect">
+            <a:avLst>
+              <a:gd name="adj" fmla="val 8000"/>
+            </a:avLst>
+          </a:prstGeom>
+          <a:solidFill>
+            <a:srgbClr val="FFFFFF"/>
+          </a:solidFill>
+          <a:ln w="19000">
+            <a:solidFill>
+              <a:srgbClr val="008BFE"/>
+            </a:solidFill>
+            <a:prstDash val="solid"/>
+          </a:ln>
+        </p:spPr>
+        <p:txBody>
+          <a:bodyPr wrap="square" lIns="0" tIns="0" rIns="0" bIns="0" rtlCol="0" anchor="ctr"/>
+          <a:lstStyle/>
+          <a:p>
+            <a:pPr marL="0" indent="0" algn="ctr">
+              <a:buNone/>
+            </a:pPr>
+            <a:r>
+              <a:rPr lang="en-US" sz="1100" b="1" dirty="0">
+                <a:solidFill>
+                  <a:srgbClr val="008BFE"/>
+                </a:solidFill>
+                <a:latin typeface="Calibri" pitchFamily="34" charset="0"/>
+              </a:rPr>
+              <a:t>Codespaces</a:t>
+            </a:r>
+          </a:p>
+        </p:txBody>
+      </p:sp>
+      <p:sp>
+        <p:nvSpPr>
+          <p:cNvPr id="44" name="ScriptingLabel"/>
+          <p:cNvSpPr/>
+          <p:nvPr/>
+        </p:nvSpPr>
+        <p:spPr>
+          <a:xfrm>
+            <a:off x="3010000" y="2450000"/>
+            <a:ext cx="2650000" cy="900000"/>
+          </a:xfrm>
+          <a:prstGeom prst="rect">
+            <a:avLst/>
+          </a:prstGeom>
+          <a:noFill/>
+          <a:ln/>
+        </p:spPr>
+        <p:txBody>
+          <a:bodyPr wrap="square" lIns="91440" tIns="45720" rIns="91440" bIns="45720" rtlCol="0" anchor="ctr"/>
+          <a:lstStyle/>
+          <a:p>
+            <a:pPr marL="0" indent="0" algn="ctr">
+              <a:buNone/>
+            </a:pPr>
+            <a:r>
+              <a:rPr lang="en-US" sz="1050" b="1" dirty="0">
+                <a:solidFill>
+                  <a:srgbClr val="333333"/>
+                </a:solidFill>
+                <a:latin typeface="Calibri" pitchFamily="34" charset="0"/>
+              </a:rPr>
+              <a:t>Preferred Scripting Language</a:t>
+            </a:r>
+          </a:p>
+          <a:p>
+            <a:pPr marL="0" indent="0" algn="ctr">
+              <a:buNone/>
+            </a:pPr>
+            <a:r>
+              <a:rPr lang="en-US" sz="950" dirty="0">
+                <a:solidFill>
+                  <a:srgbClr val="888888"/>
+                </a:solidFill>
+                <a:latin typeface="Calibri" pitchFamily="34" charset="0"/>
+              </a:rPr>
+              <a:t>(Bicep / Terraform / PowerShell)</a:t>
+            </a:r>
+          </a:p>
+        </p:txBody>
+      </p:sp>
+      <p:sp>
+        <p:nvSpPr>
+          <p:cNvPr id="50" name="Arrow2"/>
+          <p:cNvSpPr/>
+          <p:nvPr/>
+        </p:nvSpPr>
+        <p:spPr>
+          <a:xfrm>
+            <a:off x="5710000" y="2380000"/>
+            <a:ext cx="380000" cy="210000"/>
+          </a:xfrm>
+          <a:prstGeom prst="rightArrow">
+            <a:avLst>
+              <a:gd name="adj1" fmla="val 50000"/>
+              <a:gd name="adj2" fmla="val 60000"/>
+            </a:avLst>
+          </a:prstGeom>
+          <a:solidFill>
+            <a:srgbClr val="259D77"/>
+          </a:solidFill>
+          <a:ln w="12700">
+            <a:solidFill>
+              <a:srgbClr val="259D77"/>
+            </a:solidFill>
+          </a:ln>
+        </p:spPr>
+        <p:txBody>
+          <a:bodyPr/>
+          <a:lstStyle/>
+          <a:p>
+            <a:endParaRPr lang="en-AU"/>
+          </a:p>
+        </p:txBody>
+      </p:sp>
+      <p:sp>
+        <p:nvSpPr>
+          <p:cNvPr id="60" name="AzureBox"/>
+          <p:cNvSpPr/>
+          <p:nvPr/>
+        </p:nvSpPr>
+        <p:spPr>
+          <a:xfrm>
+            <a:off x="6130000" y="1420000"/>
+            <a:ext cx="2750000" cy="2150000"/>
+          </a:xfrm>
+          <a:prstGeom prst="roundRect">
+            <a:avLst>
+              <a:gd name="adj" fmla="val 5000"/>
+            </a:avLst>
+          </a:prstGeom>
+          <a:solidFill>
+            <a:srgbClr val="EBF7F3"/>
+          </a:solidFill>
+          <a:ln w="28000">
+            <a:solidFill>
+              <a:srgbClr val="259D77"/>
+            </a:solidFill>
+            <a:prstDash val="solid"/>
+          </a:ln>
+        </p:spPr>
+        <p:txBody>
+          <a:bodyPr/>
+          <a:lstStyle/>
+          <a:p>
+            <a:endParaRPr lang="en-AU"/>
+          </a:p>
+        </p:txBody>
+      </p:sp>
+      <p:sp>
+        <p:nvSpPr>
+          <p:cNvPr id="61" name="AzureLabel"/>
+          <p:cNvSpPr/>
+          <p:nvPr/>
+        </p:nvSpPr>
+        <p:spPr>
+          <a:xfrm>
+            <a:off x="6130000" y="1450000"/>
+            <a:ext cx="2750000" cy="300000"/>
+          </a:xfrm>
+          <a:prstGeom prst="rect">
+            <a:avLst/>
+          </a:prstGeom>
+          <a:noFill/>
+          <a:ln/>
+        </p:spPr>
+        <p:txBody>
+          <a:bodyPr wrap="square" lIns="0" tIns="0" rIns="0" bIns="0" rtlCol="0" anchor="ctr"/>
+          <a:lstStyle/>
+          <a:p>
+            <a:pPr marL="0" indent="0" algn="ctr">
+              <a:buNone/>
+            </a:pPr>
+            <a:r>
+              <a:rPr lang="en-US" sz="1600" b="1" dirty="0">
+                <a:solidFill>
+                  <a:srgbClr val="259D77"/>
+                </a:solidFill>
+                <a:latin typeface="Calibri" pitchFamily="34" charset="0"/>
+              </a:rPr>
+              <a:t>AZURE ENVIRONMENT</a:t>
+            </a:r>
+          </a:p>
+        </p:txBody>
+      </p:sp>
+      <p:sp>
+        <p:nvSpPr>
+          <p:cNvPr id="62" name="RGBox"/>
+          <p:cNvSpPr/>
+          <p:nvPr/>
+        </p:nvSpPr>
+        <p:spPr>
+          <a:xfrm>
+            <a:off x="6330000" y="1850000"/>
+            <a:ext cx="2350000" cy="1500000"/>
+          </a:xfrm>
+          <a:prstGeom prst="roundRect">
+            <a:avLst>
+              <a:gd name="adj" fmla="val 6000"/>
+            </a:avLst>
+          </a:prstGeom>
+          <a:solidFill>
+            <a:srgbClr val="FFFFFF"/>
+          </a:solidFill>
+          <a:ln w="19000">
+            <a:solidFill>
+              <a:srgbClr val="259D77"/>
+            </a:solidFill>
+            <a:prstDash val="dash"/>
+          </a:ln>
+        </p:spPr>
+        <p:txBody>
+          <a:bodyPr wrap="square" lIns="91440" tIns="91440" rIns="91440" bIns="91440" rtlCol="0" anchor="ctr"/>
+          <a:lstStyle/>
+          <a:p>
+            <a:pPr marL="0" indent="0" algn="ctr">
+              <a:buNone/>
+            </a:pPr>
+            <a:r>
+              <a:rPr lang="en-US" sz="1300" b="1" dirty="0">
+                <a:solidFill>
+                  <a:srgbClr val="259D77"/>
+                </a:solidFill>
+                <a:latin typeface="Calibri" pitchFamily="34" charset="0"/>
+              </a:rPr>
+              <a:t>Resource Group</a:t>
+            </a:r>
+          </a:p>
+          <a:p>
+            <a:pPr marL="0" indent="0" algn="ctr">
+              <a:buNone/>
+            </a:pPr>
+            <a:r>
+              <a:rPr lang="en-US" sz="1100" dirty="0">
+                <a:solidFill>
+                  <a:srgbClr val="888888"/>
+                </a:solidFill>
+                <a:latin typeface="Calibri" pitchFamily="34" charset="0"/>
+              </a:rPr>
+              <a:t>(RG)</a:t>
+            </a:r>
+          </a:p>
+        </p:txBody>
+      </p:sp>
+      <p:sp>
+        <p:nvSpPr>
+          <p:cNvPr id="70" name="Step1Bg"/>
+          <p:cNvSpPr/>
+          <p:nvPr/>
+        </p:nvSpPr>
+        <p:spPr>
+          <a:xfrm>
+            <a:off x="256032" y="3800000"/>
+            <a:ext cx="2050000" cy="1000000"/>
+          </a:xfrm>
+          <a:prstGeom prst="roundRect">
+            <a:avLst>
+              <a:gd name="adj" fmla="val 8000"/>
+            </a:avLst>
+          </a:prstGeom>
+          <a:solidFill>
+            <a:srgbClr val="1C8F94"/>
+          </a:solidFill>
+          <a:ln/>
+        </p:spPr>
+        <p:txBody>
+          <a:bodyPr wrap="square" lIns="91440" tIns="91440" rIns="91440" bIns="91440" rtlCol="0" anchor="ctr"/>
+          <a:lstStyle/>
+          <a:p>
+            <a:pPr marL="0" indent="0" algn="ctr">
+              <a:buNone/>
+            </a:pPr>
+            <a:r>
+              <a:rPr lang="en-US" sz="1100" b="1" dirty="0">
+                <a:solidFill>
+                  <a:srgbClr val="FFFFFF"/>
+                </a:solidFill>
+                <a:latin typeface="Calibri" pitchFamily="34" charset="0"/>
+              </a:rPr>
+              <a:t>① Setup base Repo</a:t>
+            </a:r>
+          </a:p>
+        </p:txBody>
+      </p:sp>
+      <p:sp>
+        <p:nvSpPr>
+          <p:cNvPr id="71" name="Step2Bg"/>
+          <p:cNvSpPr/>
+          <p:nvPr/>
+        </p:nvSpPr>
+        <p:spPr>
+          <a:xfrm>
+            <a:off x="2456032" y="3800000"/>
+            <a:ext cx="2050000" cy="1000000"/>
+          </a:xfrm>
+          <a:prstGeom prst="roundRect">
+            <a:avLst>
+              <a:gd name="adj" fmla="val 8000"/>
+            </a:avLst>
+          </a:prstGeom>
+          <a:solidFill>
+            <a:srgbClr val="259D77"/>
+          </a:solidFill>
+          <a:ln/>
+        </p:spPr>
+        <p:txBody>
+          <a:bodyPr wrap="square" lIns="91440" tIns="91440" rIns="91440" bIns="91440" rtlCol="0" anchor="ctr"/>
+          <a:lstStyle/>
+          <a:p>
+            <a:pPr marL="0" indent="0" algn="ctr">
+              <a:buNone/>
+            </a:pPr>
+            <a:r>
+              <a:rPr lang="en-US" sz="1100" b="1" dirty="0">
+                <a:solidFill>
+                  <a:srgbClr val="FFFFFF"/>
+                </a:solidFill>
+                <a:latin typeface="Calibri" pitchFamily="34" charset="0"/>
+              </a:rPr>
+              <a:t>② Setup base Azure</a:t>
+            </a:r>
+          </a:p>
+        </p:txBody>
+      </p:sp>
+      <p:sp>
+        <p:nvSpPr>
+          <p:cNvPr id="72" name="Step3Bg"/>
+          <p:cNvSpPr/>
+          <p:nvPr/>
+        </p:nvSpPr>
+        <p:spPr>
+          <a:xfrm>
+            <a:off x="4656032" y="3800000"/>
+            <a:ext cx="2050000" cy="1000000"/>
+          </a:xfrm>
+          <a:prstGeom prst="roundRect">
+            <a:avLst>
+              <a:gd name="adj" fmla="val 8000"/>
+            </a:avLst>
+          </a:prstGeom>
+          <a:solidFill>
+            <a:srgbClr val="1C8F94"/>
+          </a:solidFill>
+          <a:ln/>
+        </p:spPr>
+        <p:txBody>
+          <a:bodyPr wrap="square" lIns="91440" tIns="91440" rIns="91440" bIns="91440" rtlCol="0" anchor="ctr"/>
+          <a:lstStyle/>
+          <a:p>
+            <a:pPr marL="0" indent="0" algn="ctr">
+              <a:buNone/>
+            </a:pPr>
+            <a:r>
+              <a:rPr lang="en-US" sz="1100" b="1" dirty="0">
+                <a:solidFill>
+                  <a:srgbClr val="FFFFFF"/>
+                </a:solidFill>
+                <a:latin typeface="Calibri" pitchFamily="34" charset="0"/>
+              </a:rPr>
+              <a:t>③ Setup base Claude</a:t>
+            </a:r>
+          </a:p>
+        </p:txBody>
+      </p:sp>
+      <p:sp>
+        <p:nvSpPr>
+          <p:cNvPr id="73" name="Step4Bg"/>
+          <p:cNvSpPr/>
+          <p:nvPr/>
+        </p:nvSpPr>
+        <p:spPr>
+          <a:xfrm>
+            <a:off x="6856032" y="3800000"/>
+            <a:ext cx="2050000" cy="1000000"/>
+          </a:xfrm>
+          <a:prstGeom prst="roundRect">
+            <a:avLst>
+              <a:gd name="adj" fmla="val 8000"/>
+            </a:avLst>
+          </a:prstGeom>
+          <a:solidFill>
+            <a:srgbClr val="008BFE"/>
+          </a:solidFill>
+          <a:ln/>
+        </p:spPr>
+        <p:txBody>
+          <a:bodyPr wrap="square" lIns="91440" tIns="91440" rIns="91440" bIns="91440" rtlCol="0" anchor="ctr"/>
+          <a:lstStyle/>
+          <a:p>
+            <a:pPr marL="0" indent="0" algn="ctr">
+              <a:buNone/>
+            </a:pPr>
+            <a:r>
+              <a:rPr lang="en-US" sz="1100" b="1" dirty="0">
+                <a:solidFill>
+                  <a:srgbClr val="FFFFFF"/>
+                </a:solidFill>
+                <a:latin typeface="Calibri" pitchFamily="34" charset="0"/>
+              </a:rPr>
+              <a:t>④ Vibe Code ↺ Repeat</a:t>
+            </a:r>
+          </a:p>
+        </p:txBody>
+      </p:sp>
+      <p:sp>
+        <p:nvSpPr>
+          <p:cNvPr id="99" name="Footer"/>
+          <p:cNvSpPr/>
+          <p:nvPr/>
+        </p:nvSpPr>
+        <p:spPr>
+          <a:xfrm>
+            <a:off x="5934456" y="4608576"/>
+            <a:ext cx="2935224" cy="237744"/>
+          </a:xfrm>
+          <a:prstGeom prst="rect">
+            <a:avLst/>
+          </a:prstGeom>
+          <a:noFill/>
+          <a:ln/>
+        </p:spPr>
+        <p:txBody>
+          <a:bodyPr wrap="square" lIns="0" tIns="0" rIns="0" bIns="0" rtlCol="0" anchor="ctr"/>
+          <a:lstStyle/>
+          <a:p>
+            <a:pPr marL="0" indent="0" algn="r">
+              <a:buNone/>
+            </a:pPr>
+            <a:r>
+              <a:rPr lang="en-US" sz="750" i="1" dirty="0">
+                <a:solidFill>
+                  <a:srgbClr val="BBBBBB"/>
+                </a:solidFill>
+                <a:latin typeface="Calibri" pitchFamily="34" charset="0"/>
+              </a:rPr>
+              <a:t>Cloud Paradigm Pty Ltd  |  cloudparadigm.com.au</a:t>
+            </a:r>
+          </a:p>
+        </p:txBody>
+      </p:sp>
+    </p:spTree>
+  </p:cSld>
+  <p:clrMapOvr>
+    <a:masterClrMapping/>
+  </p:clrMapOvr>
+</p:sld>
+</file>
+
 <file path=ppt/slides/slide3.xml><?xml version="1.0" encoding="utf-8"?>
 <p:sld xmlns:a="http://schemas.openxmlformats.org/drawingml/2006/main" xmlns:r="http://schemas.openxmlformats.org/officeDocument/2006/relationships" xmlns:p="http://schemas.openxmlformats.org/presentationml/2006/main">
   <p:cSld name="Slide 3">

</xml_diff>